<commit_message>
Présentation : retrait de « À montrer en direct » sur la dernière diapo
Co-Authored-By: Claude Opus 5.5 <noreply@anthropic.com>
Claude-Session: https://claude.ai/code/session_015VyQwmmbHoHoipvner6q8o
</commit_message>
<xml_diff>
--- a/assets/presentation/Presentation_E5_Dorian_Pachot.pptx
+++ b/assets/presentation/Presentation_E5_Dorian_Pachot.pptx
@@ -121,14 +121,14 @@
   <p:extLst>
     <p:ext uri="{521415D9-36F7-43E2-AB2F-B90AF26B5E84}">
       <p14:sectionLst xmlns:p14="http://schemas.microsoft.com/office/powerpoint/2010/main">
-        <p14:section name="Introduction" id="{ee4357da-9260-db10-f6c3-b39d751289ad}">
+        <p14:section name="Introduction" id="{c3ccf386-886f-fd9a-754f-608d6ea96b73}">
           <p14:sldIdLst>
             <p14:sldId id="256"/>
             <p14:sldId id="257"/>
             <p14:sldId id="258"/>
           </p14:sldIdLst>
         </p14:section>
-        <p14:section name="Application de gestion de cabinet" id="{c105ffbc-ec55-94cf-2ee5-25f84eba97df}">
+        <p14:section name="Application de gestion de cabinet" id="{b006a06e-5052-fb3b-10cb-b0f59cf8839f}">
           <p14:sldIdLst>
             <p14:sldId id="259"/>
             <p14:sldId id="260"/>
@@ -140,14 +140,14 @@
             <p14:sldId id="266"/>
           </p14:sldIdLst>
         </p14:section>
-        <p14:section name="Autres réalisations" id="{e7337751-1422-4d9c-dd71-42f67b8f079d}">
+        <p14:section name="Autres réalisations" id="{2ba460b6-0ce4-dfc9-8a18-b5ff514af65d}">
           <p14:sldIdLst>
             <p14:sldId id="267"/>
             <p14:sldId id="268"/>
             <p14:sldId id="269"/>
           </p14:sldIdLst>
         </p14:section>
-        <p14:section name="Conclusion" id="{ab65936a-bd03-5fad-92e3-ac445330c0f8}">
+        <p14:section name="Conclusion" id="{db3fe6c6-17ce-afdb-88ea-a57a403ad8ab}">
           <p14:sldIdLst>
             <p14:sldId id="270"/>
           </p14:sldIdLst>
@@ -8108,56 +8108,7 @@
       </p:sp>
       <p:sp>
         <p:nvSpPr>
-          <p:cNvPr id="4" name="Text 0"/>
-          <p:cNvSpPr/>
-          <p:nvPr>
-            <p:ph idx="102" type="body" hasCustomPrompt="1"/>
-          </p:nvPr>
-        </p:nvSpPr>
-        <p:spPr>
-          <a:xfrm>
-            <a:off x="548640" y="4297680"/>
-            <a:ext cx="7315200" cy="914400"/>
-          </a:xfrm>
-          <a:prstGeom prst="rect">
-            <a:avLst/>
-          </a:prstGeom>
-          <a:noFill/>
-          <a:ln/>
-        </p:spPr>
-        <p:txBody>
-          <a:bodyPr wrap="square" rtlCol="0"/>
-          <a:lstStyle/>
-          <a:p>
-            <a:pPr indent="0" marL="0">
-              <a:buNone/>
-            </a:pPr>
-            <a:r>
-              <a:rPr lang="en-US" sz="1800" b="1" dirty="0">
-                <a:solidFill>
-                  <a:srgbClr val="FFFFFF"/>
-                </a:solidFill>
-              </a:rPr>
-              <a:t>À montrer en direct : </a:t>
-            </a:r>
-            <a:pPr indent="0" marL="0">
-              <a:buNone/>
-            </a:pPr>
-            <a:r>
-              <a:rPr lang="en-US" sz="1800" dirty="0">
-                <a:solidFill>
-                  <a:srgbClr val="C9CBD3"/>
-                </a:solidFill>
-              </a:rPr>
-              <a:t>SYNCRO sur les stores · Pla'Net · crp-assurance.com · le portfolio</a:t>
-            </a:r>
-            <a:endParaRPr lang="en-US" sz="1800" dirty="0"/>
-          </a:p>
-        </p:txBody>
-      </p:sp>
-      <p:sp>
-        <p:nvSpPr>
-          <p:cNvPr id="5" name="Lien">
+          <p:cNvPr id="4" name="Lien">
             <a:hlinkClick r:id="rId1" tooltip=""/>
           </p:cNvPr>
           <p:cNvSpPr txBox="1"/>
@@ -8202,7 +8153,7 @@
       </p:sp>
       <p:sp>
         <p:nvSpPr>
-          <p:cNvPr id="6" name="Lien">
+          <p:cNvPr id="5" name="Lien">
             <a:hlinkClick r:id="rId2" tooltip=""/>
           </p:cNvPr>
           <p:cNvSpPr txBox="1"/>
@@ -8247,7 +8198,7 @@
       </p:sp>
       <p:sp>
         <p:nvSpPr>
-          <p:cNvPr id="7" name="Lien">
+          <p:cNvPr id="6" name="Lien">
             <a:hlinkClick r:id="rId3" tooltip=""/>
           </p:cNvPr>
           <p:cNvSpPr txBox="1"/>
@@ -8286,6 +8237,36 @@
               </a:rPr>
               <a:t>CRP-Assurance</a:t>
             </a:r>
+            <a:endParaRPr lang="en-US" sz="1800" dirty="0"/>
+          </a:p>
+        </p:txBody>
+      </p:sp>
+      <p:sp>
+        <p:nvSpPr>
+          <p:cNvPr id="8" name="Text 0"/>
+          <p:cNvSpPr/>
+          <p:nvPr>
+            <p:ph idx="102" type="body" hasCustomPrompt="1"/>
+          </p:nvPr>
+        </p:nvSpPr>
+        <p:spPr>
+          <a:xfrm>
+            <a:off x="548640" y="4297680"/>
+            <a:ext cx="7315200" cy="914400"/>
+          </a:xfrm>
+          <a:prstGeom prst="rect">
+            <a:avLst/>
+          </a:prstGeom>
+          <a:noFill/>
+          <a:ln/>
+        </p:spPr>
+        <p:txBody>
+          <a:bodyPr wrap="square" rtlCol="0"/>
+          <a:lstStyle/>
+          <a:p>
+            <a:pPr indent="0" marL="0">
+              <a:buNone/>
+            </a:pPr>
             <a:endParaRPr lang="en-US" sz="1800" dirty="0"/>
           </a:p>
         </p:txBody>

</xml_diff>

<commit_message>
Présentation : tableau de synthèse complété (SYNCRO sur les 6 compétences)
Co-Authored-By: Claude Opus 5.5 <noreply@anthropic.com>
Claude-Session: https://claude.ai/code/session_015VyQwmmbHoHoipvner6q8o
</commit_message>
<xml_diff>
--- a/assets/presentation/Presentation_E5_Dorian_Pachot.pptx
+++ b/assets/presentation/Presentation_E5_Dorian_Pachot.pptx
@@ -121,14 +121,14 @@
   <p:extLst>
     <p:ext uri="{521415D9-36F7-43E2-AB2F-B90AF26B5E84}">
       <p14:sectionLst xmlns:p14="http://schemas.microsoft.com/office/powerpoint/2010/main">
-        <p14:section name="Introduction" id="{c3ccf386-886f-fd9a-754f-608d6ea96b73}">
+        <p14:section name="Introduction" id="{f32ec86b-bdb0-a014-f8fd-a22f51a17185}">
           <p14:sldIdLst>
             <p14:sldId id="256"/>
             <p14:sldId id="257"/>
             <p14:sldId id="258"/>
           </p14:sldIdLst>
         </p14:section>
-        <p14:section name="Application de gestion de cabinet" id="{b006a06e-5052-fb3b-10cb-b0f59cf8839f}">
+        <p14:section name="Application de gestion de cabinet" id="{df8c1e43-3941-e30b-f103-11dedc596cf5}">
           <p14:sldIdLst>
             <p14:sldId id="259"/>
             <p14:sldId id="260"/>
@@ -140,14 +140,14 @@
             <p14:sldId id="266"/>
           </p14:sldIdLst>
         </p14:section>
-        <p14:section name="Autres réalisations" id="{2ba460b6-0ce4-dfc9-8a18-b5ff514af65d}">
+        <p14:section name="Autres réalisations" id="{265c155d-25f5-fd15-ef80-de9d32d8fae8}">
           <p14:sldIdLst>
             <p14:sldId id="267"/>
             <p14:sldId id="268"/>
             <p14:sldId id="269"/>
           </p14:sldIdLst>
         </p14:section>
-        <p14:section name="Conclusion" id="{db3fe6c6-17ce-afdb-88ea-a57a403ad8ab}">
+        <p14:section name="Conclusion" id="{004e97b6-5927-1a3e-6a53-3e58180ec2ec}">
           <p14:sldIdLst>
             <p14:sldId id="270"/>
           </p14:sldIdLst>
@@ -1294,7 +1294,17 @@
           <a:p>
             <a:r>
               <a:rPr lang="en-US" dirty="0"/>
-              <a:t>[35 s] Voici mon tableau de synthèse. Chaque compétence est couverte au moins une fois. La ligne rouge, c'est la réalisation en milieu professionnel : SYNCRO. La ligne orange, c'est le projet que je vais détailler : l'application de gestion de cabinet, qui couvre le patrimoine (rôles, droits, sauvegardes), le mode projet (cahier des charges, cahier technique) et la mise à disposition (déploiement par cabinet).</a:t>
+              <a:t>[35 s] Voici mon tableau de synthèse. Chaque compétence est couverte plusieurs fois. La ligne rouge, c'est la réalisation en milieu professionnel : SYNCRO, qui couvre les six compétences. La ligne orange, c'est le projet que je vais détailler : l'application de gestion de cabinet.
+SI ON ME DEMANDE (pourquoi ce point est coché)
+• SYNCRO, 01 Patrimoine : rôles et permissions par groupe, serveur Linux, script de déploiement qui supprime les fichiers obsolètes.
+• SYNCRO, 02 Incidents : refus de l'App Store (connexion cassée depuis cinq jours), notifications iPhone, double blocage des créneaux après minuit.
+• SYNCRO, 03 Présence en ligne : site vitrine appsyncro.fr et ses pages légales, fiches sur l'App Store et Google Play.
+• SYNCRO, 04 Mode projet : cahier des charges, maquettes, treize écrans maquettés pour cadrer une évolution avec les responsables.
+• SYNCRO, 05 Mise à disposition : mise en production (Nginx, PM2, HTTPS), test de connexion à chaque déploiement, publication sur les deux stores, back-office pour l'équipe.
+• SYNCRO, 06 Développement pro : c'est pendant ce stage que j'ai choisi le DevOps ; veille sur les règles des stores et les versions de Flutter ; lettre de recommandation.
+• Gestion de cabinet, 01 : rôles admin et user, contrôle des droits, sauvegardes quotidiennes testées. 04 : cahier des charges et cahier technique. 05 : déploiement Docker par cabinet, recette prévue avec le client. 06 : choix techniques appuyés sur une recherche (tarifs Scaleway, plateformes gérées par Firebase), sources citées dans le cahier technique.
+• Pla'Net, 03 : application web en ligne qui exploite les données de l'école (le planning des cours).
+• CRP-Assurance, 01 : respect des règles d'utilisation des données (RGPD, mentions légales), identifiants hors du code, journal des erreurs protégé.</a:t>
             </a:r>
             <a:endParaRPr lang="en-US" dirty="0"/>
           </a:p>
@@ -10314,6 +10324,14 @@
                       <a:pPr algn="ctr" indent="0" marL="0">
                         <a:buNone/>
                       </a:pPr>
+                      <a:r>
+                        <a:rPr lang="en-US" sz="1800" dirty="0">
+                          <a:solidFill>
+                            <a:schemeClr val="accent2"/>
+                          </a:solidFill>
+                        </a:rPr>
+                        <a:t>●</a:t>
+                      </a:r>
                       <a:endParaRPr lang="en-US" sz="1800" dirty="0"/>
                     </a:p>
                   </a:txBody>
@@ -10746,6 +10764,14 @@
                       <a:pPr algn="ctr" indent="0" marL="0">
                         <a:buNone/>
                       </a:pPr>
+                      <a:r>
+                        <a:rPr lang="en-US" sz="1800" dirty="0">
+                          <a:solidFill>
+                            <a:schemeClr val="accent1"/>
+                          </a:solidFill>
+                        </a:rPr>
+                        <a:t>●</a:t>
+                      </a:r>
                       <a:endParaRPr lang="en-US" sz="1800" dirty="0"/>
                     </a:p>
                   </a:txBody>
@@ -10978,6 +11004,14 @@
                       <a:pPr algn="ctr" indent="0" marL="0">
                         <a:buNone/>
                       </a:pPr>
+                      <a:r>
+                        <a:rPr lang="en-US" sz="1800" dirty="0">
+                          <a:solidFill>
+                            <a:schemeClr val="accent1"/>
+                          </a:solidFill>
+                        </a:rPr>
+                        <a:t>●</a:t>
+                      </a:r>
                       <a:endParaRPr lang="en-US" sz="1800" dirty="0"/>
                     </a:p>
                   </a:txBody>
@@ -11265,6 +11299,14 @@
                       <a:pPr algn="ctr" indent="0" marL="0">
                         <a:buNone/>
                       </a:pPr>
+                      <a:r>
+                        <a:rPr lang="en-US" sz="1800" dirty="0">
+                          <a:solidFill>
+                            <a:schemeClr val="accent1"/>
+                          </a:solidFill>
+                        </a:rPr>
+                        <a:t>●</a:t>
+                      </a:r>
                       <a:endParaRPr lang="en-US" sz="1800" dirty="0"/>
                     </a:p>
                   </a:txBody>

</xml_diff>

<commit_message>
Vraies captures de SYNCRO, numéros 01, 02, 03 retirés
Co-Authored-By: Claude Opus 5.5 <noreply@anthropic.com>
Claude-Session: https://claude.ai/code/session_015VyQwmmbHoHoipvner6q8o
</commit_message>
<xml_diff>
--- a/assets/presentation/Presentation_E5_Dorian_Pachot.pptx
+++ b/assets/presentation/Presentation_E5_Dorian_Pachot.pptx
@@ -121,14 +121,14 @@
   <p:extLst>
     <p:ext uri="{521415D9-36F7-43E2-AB2F-B90AF26B5E84}">
       <p14:sectionLst xmlns:p14="http://schemas.microsoft.com/office/powerpoint/2010/main">
-        <p14:section name="Introduction" id="{f32ec86b-bdb0-a014-f8fd-a22f51a17185}">
+        <p14:section name="Introduction" id="{2950ab1a-a7e7-a62d-cfd0-3320e2d9d140}">
           <p14:sldIdLst>
             <p14:sldId id="256"/>
             <p14:sldId id="257"/>
             <p14:sldId id="258"/>
           </p14:sldIdLst>
         </p14:section>
-        <p14:section name="Application de gestion de cabinet" id="{df8c1e43-3941-e30b-f103-11dedc596cf5}">
+        <p14:section name="Application de gestion de cabinet" id="{bbac6e17-d6da-a54e-d46e-31427a70879c}">
           <p14:sldIdLst>
             <p14:sldId id="259"/>
             <p14:sldId id="260"/>
@@ -140,14 +140,14 @@
             <p14:sldId id="266"/>
           </p14:sldIdLst>
         </p14:section>
-        <p14:section name="Autres réalisations" id="{265c155d-25f5-fd15-ef80-de9d32d8fae8}">
+        <p14:section name="Autres réalisations" id="{5d7839a6-ba92-82aa-536a-d255911838e5}">
           <p14:sldIdLst>
             <p14:sldId id="267"/>
             <p14:sldId id="268"/>
             <p14:sldId id="269"/>
           </p14:sldIdLst>
         </p14:section>
-        <p14:section name="Conclusion" id="{004e97b6-5927-1a3e-6a53-3e58180ec2ec}">
+        <p14:section name="Conclusion" id="{3cdb03b2-1561-03f4-411c-5d562103f301}">
           <p14:sldIdLst>
             <p14:sldId id="270"/>
           </p14:sldIdLst>
@@ -6088,7 +6088,7 @@
         <p:spPr>
           <a:xfrm>
             <a:off x="7269480" y="1874520"/>
-            <a:ext cx="1371600" cy="2438400"/>
+            <a:ext cx="1238441" cy="2682240"/>
           </a:xfrm>
           <a:prstGeom prst="rect">
             <a:avLst/>
@@ -6112,7 +6112,7 @@
         <p:spPr>
           <a:xfrm>
             <a:off x="8750808" y="1600200"/>
-            <a:ext cx="1371600" cy="2438400"/>
+            <a:ext cx="1238441" cy="2682240"/>
           </a:xfrm>
           <a:prstGeom prst="rect">
             <a:avLst/>
@@ -6136,7 +6136,7 @@
         <p:spPr>
           <a:xfrm>
             <a:off x="10232136" y="1874520"/>
-            <a:ext cx="1371600" cy="2438400"/>
+            <a:ext cx="1238441" cy="2682240"/>
           </a:xfrm>
           <a:prstGeom prst="rect">
             <a:avLst/>
@@ -7027,7 +7027,7 @@
         <p:spPr>
           <a:xfrm>
             <a:off x="548640" y="1645920"/>
-            <a:ext cx="548640" cy="365760"/>
+            <a:ext cx="5669280" cy="347472"/>
           </a:xfrm>
           <a:prstGeom prst="rect">
             <a:avLst/>
@@ -7043,14 +7043,14 @@
               <a:buNone/>
             </a:pPr>
             <a:r>
-              <a:rPr lang="en-US" sz="1600" b="1" dirty="0">
-                <a:solidFill>
-                  <a:schemeClr val="accent1"/>
+              <a:rPr lang="en-US" sz="1700" b="1" dirty="0">
+                <a:solidFill>
+                  <a:schemeClr val="tx1"/>
                 </a:solidFill>
               </a:rPr>
-              <a:t>01</a:t>
-            </a:r>
-            <a:endParaRPr lang="en-US" sz="1600" dirty="0"/>
+              <a:t>Des sources</a:t>
+            </a:r>
+            <a:endParaRPr lang="en-US" sz="1700" dirty="0"/>
           </a:p>
         </p:txBody>
       </p:sp>
@@ -7062,8 +7062,8 @@
         </p:nvSpPr>
         <p:spPr>
           <a:xfrm>
-            <a:off x="1188720" y="1645920"/>
-            <a:ext cx="5029200" cy="347472"/>
+            <a:off x="548640" y="2011680"/>
+            <a:ext cx="5669280" cy="365760"/>
           </a:xfrm>
           <a:prstGeom prst="rect">
             <a:avLst/>
@@ -7079,14 +7079,14 @@
               <a:buNone/>
             </a:pPr>
             <a:r>
-              <a:rPr lang="en-US" sz="1700" b="1" dirty="0">
-                <a:solidFill>
-                  <a:schemeClr val="tx1"/>
+              <a:rPr lang="en-US" sz="1400" dirty="0">
+                <a:solidFill>
+                  <a:schemeClr val="accent5"/>
                 </a:solidFill>
               </a:rPr>
-              <a:t>Des sources</a:t>
-            </a:r>
-            <a:endParaRPr lang="en-US" sz="1700" dirty="0"/>
+              <a:t>Alertes Google, notes de version, règles des stores</a:t>
+            </a:r>
+            <a:endParaRPr lang="en-US" sz="1400" dirty="0"/>
           </a:p>
         </p:txBody>
       </p:sp>
@@ -7098,8 +7098,8 @@
         </p:nvSpPr>
         <p:spPr>
           <a:xfrm>
-            <a:off x="1188720" y="2011680"/>
-            <a:ext cx="5029200" cy="365760"/>
+            <a:off x="548640" y="2560320"/>
+            <a:ext cx="5669280" cy="347472"/>
           </a:xfrm>
           <a:prstGeom prst="rect">
             <a:avLst/>
@@ -7115,14 +7115,14 @@
               <a:buNone/>
             </a:pPr>
             <a:r>
-              <a:rPr lang="en-US" sz="1400" dirty="0">
-                <a:solidFill>
-                  <a:schemeClr val="accent5"/>
+              <a:rPr lang="en-US" sz="1700" b="1" dirty="0">
+                <a:solidFill>
+                  <a:schemeClr val="tx1"/>
                 </a:solidFill>
               </a:rPr>
-              <a:t>Alertes Google, notes de version, règles des stores</a:t>
-            </a:r>
-            <a:endParaRPr lang="en-US" sz="1400" dirty="0"/>
+              <a:t>Un tri</a:t>
+            </a:r>
+            <a:endParaRPr lang="en-US" sz="1700" dirty="0"/>
           </a:p>
         </p:txBody>
       </p:sp>
@@ -7134,8 +7134,8 @@
         </p:nvSpPr>
         <p:spPr>
           <a:xfrm>
-            <a:off x="548640" y="2560320"/>
-            <a:ext cx="548640" cy="365760"/>
+            <a:off x="548640" y="2926080"/>
+            <a:ext cx="5669280" cy="365760"/>
           </a:xfrm>
           <a:prstGeom prst="rect">
             <a:avLst/>
@@ -7151,14 +7151,14 @@
               <a:buNone/>
             </a:pPr>
             <a:r>
-              <a:rPr lang="en-US" sz="1600" b="1" dirty="0">
-                <a:solidFill>
-                  <a:schemeClr val="accent1"/>
+              <a:rPr lang="en-US" sz="1400" dirty="0">
+                <a:solidFill>
+                  <a:schemeClr val="accent5"/>
                 </a:solidFill>
               </a:rPr>
-              <a:t>02</a:t>
-            </a:r>
-            <a:endParaRPr lang="en-US" sz="1600" dirty="0"/>
+              <a:t>Projet, cours ou métier visé ? Sinon, je ne garde pas</a:t>
+            </a:r>
+            <a:endParaRPr lang="en-US" sz="1400" dirty="0"/>
           </a:p>
         </p:txBody>
       </p:sp>
@@ -7170,8 +7170,8 @@
         </p:nvSpPr>
         <p:spPr>
           <a:xfrm>
-            <a:off x="1188720" y="2560320"/>
-            <a:ext cx="5029200" cy="347472"/>
+            <a:off x="548640" y="3474720"/>
+            <a:ext cx="5669280" cy="347472"/>
           </a:xfrm>
           <a:prstGeom prst="rect">
             <a:avLst/>
@@ -7192,7 +7192,7 @@
                   <a:schemeClr val="tx1"/>
                 </a:solidFill>
               </a:rPr>
-              <a:t>Un tri</a:t>
+              <a:t>Une lecture critique</a:t>
             </a:r>
             <a:endParaRPr lang="en-US" sz="1700" dirty="0"/>
           </a:p>
@@ -7206,8 +7206,8 @@
         </p:nvSpPr>
         <p:spPr>
           <a:xfrm>
-            <a:off x="1188720" y="2926080"/>
-            <a:ext cx="5029200" cy="365760"/>
+            <a:off x="548640" y="3840480"/>
+            <a:ext cx="5669280" cy="365760"/>
           </a:xfrm>
           <a:prstGeom prst="rect">
             <a:avLst/>
@@ -7228,7 +7228,7 @@
                   <a:schemeClr val="accent5"/>
                 </a:solidFill>
               </a:rPr>
-              <a:t>Projet, cours ou métier visé ? Sinon, je ne garde pas</a:t>
+              <a:t>Source, date, deuxième source</a:t>
             </a:r>
             <a:endParaRPr lang="en-US" sz="1400" dirty="0"/>
           </a:p>
@@ -7242,8 +7242,8 @@
         </p:nvSpPr>
         <p:spPr>
           <a:xfrm>
-            <a:off x="548640" y="3474720"/>
-            <a:ext cx="548640" cy="365760"/>
+            <a:off x="548640" y="4389120"/>
+            <a:ext cx="5669280" cy="347472"/>
           </a:xfrm>
           <a:prstGeom prst="rect">
             <a:avLst/>
@@ -7259,14 +7259,14 @@
               <a:buNone/>
             </a:pPr>
             <a:r>
-              <a:rPr lang="en-US" sz="1600" b="1" dirty="0">
-                <a:solidFill>
-                  <a:schemeClr val="accent1"/>
+              <a:rPr lang="en-US" sz="1700" b="1" dirty="0">
+                <a:solidFill>
+                  <a:schemeClr val="tx1"/>
                 </a:solidFill>
               </a:rPr>
-              <a:t>03</a:t>
-            </a:r>
-            <a:endParaRPr lang="en-US" sz="1600" dirty="0"/>
+              <a:t>Une trace</a:t>
+            </a:r>
+            <a:endParaRPr lang="en-US" sz="1700" dirty="0"/>
           </a:p>
         </p:txBody>
       </p:sp>
@@ -7278,8 +7278,8 @@
         </p:nvSpPr>
         <p:spPr>
           <a:xfrm>
-            <a:off x="1188720" y="3474720"/>
-            <a:ext cx="5029200" cy="347472"/>
+            <a:off x="548640" y="4754880"/>
+            <a:ext cx="5669280" cy="365760"/>
           </a:xfrm>
           <a:prstGeom prst="rect">
             <a:avLst/>
@@ -7295,150 +7295,6 @@
               <a:buNone/>
             </a:pPr>
             <a:r>
-              <a:rPr lang="en-US" sz="1700" b="1" dirty="0">
-                <a:solidFill>
-                  <a:schemeClr val="tx1"/>
-                </a:solidFill>
-              </a:rPr>
-              <a:t>Une lecture critique</a:t>
-            </a:r>
-            <a:endParaRPr lang="en-US" sz="1700" dirty="0"/>
-          </a:p>
-        </p:txBody>
-      </p:sp>
-      <p:sp>
-        <p:nvSpPr>
-          <p:cNvPr id="12" name="Text 10"/>
-          <p:cNvSpPr txBox="1"/>
-          <p:nvPr/>
-        </p:nvSpPr>
-        <p:spPr>
-          <a:xfrm>
-            <a:off x="1188720" y="3840480"/>
-            <a:ext cx="5029200" cy="365760"/>
-          </a:xfrm>
-          <a:prstGeom prst="rect">
-            <a:avLst/>
-          </a:prstGeom>
-          <a:noFill/>
-          <a:ln/>
-        </p:spPr>
-        <p:txBody>
-          <a:bodyPr wrap="square" lIns="0" tIns="0" rIns="0" bIns="0" rtlCol="0" anchor="t"/>
-          <a:lstStyle/>
-          <a:p>
-            <a:pPr indent="0" marL="0">
-              <a:buNone/>
-            </a:pPr>
-            <a:r>
-              <a:rPr lang="en-US" sz="1400" dirty="0">
-                <a:solidFill>
-                  <a:schemeClr val="accent5"/>
-                </a:solidFill>
-              </a:rPr>
-              <a:t>Source, date, deuxième source</a:t>
-            </a:r>
-            <a:endParaRPr lang="en-US" sz="1400" dirty="0"/>
-          </a:p>
-        </p:txBody>
-      </p:sp>
-      <p:sp>
-        <p:nvSpPr>
-          <p:cNvPr id="13" name="Text 11"/>
-          <p:cNvSpPr txBox="1"/>
-          <p:nvPr/>
-        </p:nvSpPr>
-        <p:spPr>
-          <a:xfrm>
-            <a:off x="548640" y="4389120"/>
-            <a:ext cx="548640" cy="365760"/>
-          </a:xfrm>
-          <a:prstGeom prst="rect">
-            <a:avLst/>
-          </a:prstGeom>
-          <a:noFill/>
-          <a:ln/>
-        </p:spPr>
-        <p:txBody>
-          <a:bodyPr wrap="square" lIns="0" tIns="0" rIns="0" bIns="0" rtlCol="0" anchor="t"/>
-          <a:lstStyle/>
-          <a:p>
-            <a:pPr indent="0" marL="0">
-              <a:buNone/>
-            </a:pPr>
-            <a:r>
-              <a:rPr lang="en-US" sz="1600" b="1" dirty="0">
-                <a:solidFill>
-                  <a:schemeClr val="accent1"/>
-                </a:solidFill>
-              </a:rPr>
-              <a:t>04</a:t>
-            </a:r>
-            <a:endParaRPr lang="en-US" sz="1600" dirty="0"/>
-          </a:p>
-        </p:txBody>
-      </p:sp>
-      <p:sp>
-        <p:nvSpPr>
-          <p:cNvPr id="14" name="Text 12"/>
-          <p:cNvSpPr txBox="1"/>
-          <p:nvPr/>
-        </p:nvSpPr>
-        <p:spPr>
-          <a:xfrm>
-            <a:off x="1188720" y="4389120"/>
-            <a:ext cx="5029200" cy="347472"/>
-          </a:xfrm>
-          <a:prstGeom prst="rect">
-            <a:avLst/>
-          </a:prstGeom>
-          <a:noFill/>
-          <a:ln/>
-        </p:spPr>
-        <p:txBody>
-          <a:bodyPr wrap="square" lIns="0" tIns="0" rIns="0" bIns="0" rtlCol="0" anchor="t"/>
-          <a:lstStyle/>
-          <a:p>
-            <a:pPr indent="0" marL="0">
-              <a:buNone/>
-            </a:pPr>
-            <a:r>
-              <a:rPr lang="en-US" sz="1700" b="1" dirty="0">
-                <a:solidFill>
-                  <a:schemeClr val="tx1"/>
-                </a:solidFill>
-              </a:rPr>
-              <a:t>Une trace</a:t>
-            </a:r>
-            <a:endParaRPr lang="en-US" sz="1700" dirty="0"/>
-          </a:p>
-        </p:txBody>
-      </p:sp>
-      <p:sp>
-        <p:nvSpPr>
-          <p:cNvPr id="15" name="Text 13"/>
-          <p:cNvSpPr txBox="1"/>
-          <p:nvPr/>
-        </p:nvSpPr>
-        <p:spPr>
-          <a:xfrm>
-            <a:off x="1188720" y="4754880"/>
-            <a:ext cx="5029200" cy="365760"/>
-          </a:xfrm>
-          <a:prstGeom prst="rect">
-            <a:avLst/>
-          </a:prstGeom>
-          <a:noFill/>
-          <a:ln/>
-        </p:spPr>
-        <p:txBody>
-          <a:bodyPr wrap="square" lIns="0" tIns="0" rIns="0" bIns="0" rtlCol="0" anchor="t"/>
-          <a:lstStyle/>
-          <a:p>
-            <a:pPr indent="0" marL="0">
-              <a:buNone/>
-            </a:pPr>
-            <a:r>
               <a:rPr lang="en-US" sz="1400" dirty="0">
                 <a:solidFill>
                   <a:schemeClr val="accent5"/>
@@ -7452,7 +7308,7 @@
       </p:sp>
       <p:sp>
         <p:nvSpPr>
-          <p:cNvPr id="16" name="Carte"/>
+          <p:cNvPr id="12" name="Carte"/>
           <p:cNvSpPr/>
           <p:nvPr/>
         </p:nvSpPr>
@@ -7481,7 +7337,7 @@
       </p:sp>
       <p:sp>
         <p:nvSpPr>
-          <p:cNvPr id="17" name="Text 15"/>
+          <p:cNvPr id="13" name="Text 11"/>
           <p:cNvSpPr txBox="1"/>
           <p:nvPr/>
         </p:nvSpPr>
@@ -7517,7 +7373,7 @@
       </p:sp>
       <p:sp>
         <p:nvSpPr>
-          <p:cNvPr id="18" name="Text 16"/>
+          <p:cNvPr id="14" name="Text 12"/>
           <p:cNvSpPr txBox="1"/>
           <p:nvPr/>
         </p:nvSpPr>
@@ -7556,7 +7412,7 @@
       </p:sp>
       <p:sp>
         <p:nvSpPr>
-          <p:cNvPr id="19" name="Text 17"/>
+          <p:cNvPr id="15" name="Text 13"/>
           <p:cNvSpPr txBox="1"/>
           <p:nvPr/>
         </p:nvSpPr>
@@ -7592,7 +7448,7 @@
       </p:sp>
       <p:sp>
         <p:nvSpPr>
-          <p:cNvPr id="20" name="Carte"/>
+          <p:cNvPr id="16" name="Carte"/>
           <p:cNvSpPr/>
           <p:nvPr/>
         </p:nvSpPr>
@@ -7626,7 +7482,7 @@
       </p:sp>
       <p:sp>
         <p:nvSpPr>
-          <p:cNvPr id="21" name="Text 19"/>
+          <p:cNvPr id="17" name="Text 15"/>
           <p:cNvSpPr txBox="1"/>
           <p:nvPr/>
         </p:nvSpPr>
@@ -7662,7 +7518,7 @@
       </p:sp>
       <p:sp>
         <p:nvSpPr>
-          <p:cNvPr id="22" name="Text 20"/>
+          <p:cNvPr id="18" name="Text 16"/>
           <p:cNvSpPr txBox="1"/>
           <p:nvPr/>
         </p:nvSpPr>
@@ -7701,7 +7557,7 @@
       </p:sp>
       <p:sp>
         <p:nvSpPr>
-          <p:cNvPr id="23" name="Pastille"/>
+          <p:cNvPr id="19" name="Pastille"/>
           <p:cNvSpPr/>
           <p:nvPr/>
         </p:nvSpPr>
@@ -7732,7 +7588,7 @@
       </p:sp>
       <p:sp>
         <p:nvSpPr>
-          <p:cNvPr id="24" name="Pastille texte"/>
+          <p:cNvPr id="20" name="Pastille texte"/>
           <p:cNvSpPr txBox="1"/>
           <p:nvPr/>
         </p:nvSpPr>
@@ -7768,7 +7624,7 @@
       </p:sp>
       <p:sp>
         <p:nvSpPr>
-          <p:cNvPr id="25" name="Pastille"/>
+          <p:cNvPr id="21" name="Pastille"/>
           <p:cNvSpPr/>
           <p:nvPr/>
         </p:nvSpPr>
@@ -7799,7 +7655,7 @@
       </p:sp>
       <p:sp>
         <p:nvSpPr>
-          <p:cNvPr id="26" name="Pastille texte"/>
+          <p:cNvPr id="22" name="Pastille texte"/>
           <p:cNvSpPr txBox="1"/>
           <p:nvPr/>
         </p:nvSpPr>
@@ -7835,7 +7691,7 @@
       </p:sp>
       <p:sp>
         <p:nvSpPr>
-          <p:cNvPr id="27" name="Pastille"/>
+          <p:cNvPr id="23" name="Pastille"/>
           <p:cNvSpPr/>
           <p:nvPr/>
         </p:nvSpPr>
@@ -7866,7 +7722,7 @@
       </p:sp>
       <p:sp>
         <p:nvSpPr>
-          <p:cNvPr id="28" name="Pastille texte"/>
+          <p:cNvPr id="24" name="Pastille texte"/>
           <p:cNvSpPr txBox="1"/>
           <p:nvPr/>
         </p:nvSpPr>
@@ -7902,7 +7758,7 @@
       </p:sp>
       <p:sp>
         <p:nvSpPr>
-          <p:cNvPr id="29" name="Pastille"/>
+          <p:cNvPr id="25" name="Pastille"/>
           <p:cNvSpPr/>
           <p:nvPr/>
         </p:nvSpPr>
@@ -7933,7 +7789,7 @@
       </p:sp>
       <p:sp>
         <p:nvSpPr>
-          <p:cNvPr id="30" name="Pastille texte"/>
+          <p:cNvPr id="26" name="Pastille texte"/>
           <p:cNvSpPr txBox="1"/>
           <p:nvPr/>
         </p:nvSpPr>
@@ -9619,7 +9475,7 @@
                             <a:schemeClr val="accent5"/>
                           </a:solidFill>
                         </a:rPr>
-                        <a:t>01  Patrimoine</a:t>
+                        <a:t>Patrimoine</a:t>
                       </a:r>
                       <a:endParaRPr lang="en-US" sz="1200" dirty="0"/>
                     </a:p>
@@ -9677,7 +9533,7 @@
                             <a:schemeClr val="accent5"/>
                           </a:solidFill>
                         </a:rPr>
-                        <a:t>02  Incidents</a:t>
+                        <a:t>Incidents</a:t>
                       </a:r>
                       <a:endParaRPr lang="en-US" sz="1200" dirty="0"/>
                     </a:p>
@@ -9735,7 +9591,7 @@
                             <a:schemeClr val="accent5"/>
                           </a:solidFill>
                         </a:rPr>
-                        <a:t>03  Présence en ligne</a:t>
+                        <a:t>Présence en ligne</a:t>
                       </a:r>
                       <a:endParaRPr lang="en-US" sz="1200" dirty="0"/>
                     </a:p>
@@ -9793,7 +9649,7 @@
                             <a:schemeClr val="accent5"/>
                           </a:solidFill>
                         </a:rPr>
-                        <a:t>04  Mode projet</a:t>
+                        <a:t>Mode projet</a:t>
                       </a:r>
                       <a:endParaRPr lang="en-US" sz="1200" dirty="0"/>
                     </a:p>
@@ -9851,7 +9707,7 @@
                             <a:schemeClr val="accent5"/>
                           </a:solidFill>
                         </a:rPr>
-                        <a:t>05  Mise à disposition</a:t>
+                        <a:t>Mise à disposition</a:t>
                       </a:r>
                       <a:endParaRPr lang="en-US" sz="1200" dirty="0"/>
                     </a:p>
@@ -9909,7 +9765,7 @@
                             <a:schemeClr val="accent5"/>
                           </a:solidFill>
                         </a:rPr>
-                        <a:t>06  Dév. pro</a:t>
+                        <a:t>Dév. pro</a:t>
                       </a:r>
                       <a:endParaRPr lang="en-US" sz="1200" dirty="0"/>
                     </a:p>
@@ -15342,8 +15198,8 @@
         </p:nvSpPr>
         <p:spPr>
           <a:xfrm>
-            <a:off x="5257800" y="1645920"/>
-            <a:ext cx="457200" cy="603504"/>
+            <a:off x="5303520" y="1645920"/>
+            <a:ext cx="2834640" cy="603504"/>
           </a:xfrm>
           <a:prstGeom prst="rect">
             <a:avLst/>
@@ -15359,42 +15215,6 @@
               <a:buNone/>
             </a:pPr>
             <a:r>
-              <a:rPr lang="en-US" sz="1300" b="1" dirty="0">
-                <a:solidFill>
-                  <a:schemeClr val="accent2"/>
-                </a:solidFill>
-              </a:rPr>
-              <a:t>01</a:t>
-            </a:r>
-            <a:endParaRPr lang="en-US" sz="1300" dirty="0"/>
-          </a:p>
-        </p:txBody>
-      </p:sp>
-      <p:sp>
-        <p:nvSpPr>
-          <p:cNvPr id="14" name="Text 12"/>
-          <p:cNvSpPr txBox="1"/>
-          <p:nvPr/>
-        </p:nvSpPr>
-        <p:spPr>
-          <a:xfrm>
-            <a:off x="5715000" y="1645920"/>
-            <a:ext cx="2423160" cy="603504"/>
-          </a:xfrm>
-          <a:prstGeom prst="rect">
-            <a:avLst/>
-          </a:prstGeom>
-          <a:noFill/>
-          <a:ln/>
-        </p:spPr>
-        <p:txBody>
-          <a:bodyPr wrap="square" lIns="0" tIns="0" rIns="0" bIns="0" rtlCol="0" anchor="ctr"/>
-          <a:lstStyle/>
-          <a:p>
-            <a:pPr indent="0" marL="0">
-              <a:buNone/>
-            </a:pPr>
-            <a:r>
               <a:rPr lang="en-US" sz="1500" b="1" dirty="0">
                 <a:solidFill>
                   <a:schemeClr val="tx1"/>
@@ -15408,7 +15228,7 @@
       </p:sp>
       <p:sp>
         <p:nvSpPr>
-          <p:cNvPr id="15" name="Carte"/>
+          <p:cNvPr id="14" name="Carte"/>
           <p:cNvSpPr/>
           <p:nvPr/>
         </p:nvSpPr>
@@ -15435,14 +15255,14 @@
       </p:sp>
       <p:sp>
         <p:nvSpPr>
-          <p:cNvPr id="16" name="Text 14"/>
+          <p:cNvPr id="15" name="Text 13"/>
           <p:cNvSpPr txBox="1"/>
           <p:nvPr/>
         </p:nvSpPr>
         <p:spPr>
           <a:xfrm>
-            <a:off x="8549640" y="1645920"/>
-            <a:ext cx="457200" cy="603504"/>
+            <a:off x="8595360" y="1645920"/>
+            <a:ext cx="2834640" cy="603504"/>
           </a:xfrm>
           <a:prstGeom prst="rect">
             <a:avLst/>
@@ -15458,42 +15278,6 @@
               <a:buNone/>
             </a:pPr>
             <a:r>
-              <a:rPr lang="en-US" sz="1300" b="1" dirty="0">
-                <a:solidFill>
-                  <a:schemeClr val="accent2"/>
-                </a:solidFill>
-              </a:rPr>
-              <a:t>02</a:t>
-            </a:r>
-            <a:endParaRPr lang="en-US" sz="1300" dirty="0"/>
-          </a:p>
-        </p:txBody>
-      </p:sp>
-      <p:sp>
-        <p:nvSpPr>
-          <p:cNvPr id="17" name="Text 15"/>
-          <p:cNvSpPr txBox="1"/>
-          <p:nvPr/>
-        </p:nvSpPr>
-        <p:spPr>
-          <a:xfrm>
-            <a:off x="9006840" y="1645920"/>
-            <a:ext cx="2423160" cy="603504"/>
-          </a:xfrm>
-          <a:prstGeom prst="rect">
-            <a:avLst/>
-          </a:prstGeom>
-          <a:noFill/>
-          <a:ln/>
-        </p:spPr>
-        <p:txBody>
-          <a:bodyPr wrap="square" lIns="0" tIns="0" rIns="0" bIns="0" rtlCol="0" anchor="ctr"/>
-          <a:lstStyle/>
-          <a:p>
-            <a:pPr indent="0" marL="0">
-              <a:buNone/>
-            </a:pPr>
-            <a:r>
               <a:rPr lang="en-US" sz="1500" b="1" dirty="0">
                 <a:solidFill>
                   <a:schemeClr val="tx1"/>
@@ -15507,7 +15291,7 @@
       </p:sp>
       <p:sp>
         <p:nvSpPr>
-          <p:cNvPr id="18" name="Carte"/>
+          <p:cNvPr id="16" name="Carte"/>
           <p:cNvSpPr/>
           <p:nvPr/>
         </p:nvSpPr>
@@ -15534,14 +15318,14 @@
       </p:sp>
       <p:sp>
         <p:nvSpPr>
-          <p:cNvPr id="19" name="Text 17"/>
+          <p:cNvPr id="17" name="Text 15"/>
           <p:cNvSpPr txBox="1"/>
           <p:nvPr/>
         </p:nvSpPr>
         <p:spPr>
           <a:xfrm>
-            <a:off x="5257800" y="2377440"/>
-            <a:ext cx="457200" cy="603504"/>
+            <a:off x="5303520" y="2377440"/>
+            <a:ext cx="2834640" cy="603504"/>
           </a:xfrm>
           <a:prstGeom prst="rect">
             <a:avLst/>
@@ -15557,42 +15341,6 @@
               <a:buNone/>
             </a:pPr>
             <a:r>
-              <a:rPr lang="en-US" sz="1300" b="1" dirty="0">
-                <a:solidFill>
-                  <a:schemeClr val="accent2"/>
-                </a:solidFill>
-              </a:rPr>
-              <a:t>03</a:t>
-            </a:r>
-            <a:endParaRPr lang="en-US" sz="1300" dirty="0"/>
-          </a:p>
-        </p:txBody>
-      </p:sp>
-      <p:sp>
-        <p:nvSpPr>
-          <p:cNvPr id="20" name="Text 18"/>
-          <p:cNvSpPr txBox="1"/>
-          <p:nvPr/>
-        </p:nvSpPr>
-        <p:spPr>
-          <a:xfrm>
-            <a:off x="5715000" y="2377440"/>
-            <a:ext cx="2423160" cy="603504"/>
-          </a:xfrm>
-          <a:prstGeom prst="rect">
-            <a:avLst/>
-          </a:prstGeom>
-          <a:noFill/>
-          <a:ln/>
-        </p:spPr>
-        <p:txBody>
-          <a:bodyPr wrap="square" lIns="0" tIns="0" rIns="0" bIns="0" rtlCol="0" anchor="ctr"/>
-          <a:lstStyle/>
-          <a:p>
-            <a:pPr indent="0" marL="0">
-              <a:buNone/>
-            </a:pPr>
-            <a:r>
               <a:rPr lang="en-US" sz="1500" b="1" dirty="0">
                 <a:solidFill>
                   <a:schemeClr val="tx1"/>
@@ -15606,7 +15354,7 @@
       </p:sp>
       <p:sp>
         <p:nvSpPr>
-          <p:cNvPr id="21" name="Carte"/>
+          <p:cNvPr id="18" name="Carte"/>
           <p:cNvSpPr/>
           <p:nvPr/>
         </p:nvSpPr>
@@ -15633,14 +15381,14 @@
       </p:sp>
       <p:sp>
         <p:nvSpPr>
-          <p:cNvPr id="22" name="Text 20"/>
+          <p:cNvPr id="19" name="Text 17"/>
           <p:cNvSpPr txBox="1"/>
           <p:nvPr/>
         </p:nvSpPr>
         <p:spPr>
           <a:xfrm>
-            <a:off x="8549640" y="2377440"/>
-            <a:ext cx="457200" cy="603504"/>
+            <a:off x="8595360" y="2377440"/>
+            <a:ext cx="2834640" cy="603504"/>
           </a:xfrm>
           <a:prstGeom prst="rect">
             <a:avLst/>
@@ -15656,42 +15404,6 @@
               <a:buNone/>
             </a:pPr>
             <a:r>
-              <a:rPr lang="en-US" sz="1300" b="1" dirty="0">
-                <a:solidFill>
-                  <a:schemeClr val="accent2"/>
-                </a:solidFill>
-              </a:rPr>
-              <a:t>04</a:t>
-            </a:r>
-            <a:endParaRPr lang="en-US" sz="1300" dirty="0"/>
-          </a:p>
-        </p:txBody>
-      </p:sp>
-      <p:sp>
-        <p:nvSpPr>
-          <p:cNvPr id="23" name="Text 21"/>
-          <p:cNvSpPr txBox="1"/>
-          <p:nvPr/>
-        </p:nvSpPr>
-        <p:spPr>
-          <a:xfrm>
-            <a:off x="9006840" y="2377440"/>
-            <a:ext cx="2423160" cy="603504"/>
-          </a:xfrm>
-          <a:prstGeom prst="rect">
-            <a:avLst/>
-          </a:prstGeom>
-          <a:noFill/>
-          <a:ln/>
-        </p:spPr>
-        <p:txBody>
-          <a:bodyPr wrap="square" lIns="0" tIns="0" rIns="0" bIns="0" rtlCol="0" anchor="ctr"/>
-          <a:lstStyle/>
-          <a:p>
-            <a:pPr indent="0" marL="0">
-              <a:buNone/>
-            </a:pPr>
-            <a:r>
               <a:rPr lang="en-US" sz="1500" b="1" dirty="0">
                 <a:solidFill>
                   <a:schemeClr val="tx1"/>
@@ -15705,7 +15417,7 @@
       </p:sp>
       <p:sp>
         <p:nvSpPr>
-          <p:cNvPr id="24" name="Carte"/>
+          <p:cNvPr id="20" name="Carte"/>
           <p:cNvSpPr/>
           <p:nvPr/>
         </p:nvSpPr>
@@ -15732,14 +15444,14 @@
       </p:sp>
       <p:sp>
         <p:nvSpPr>
-          <p:cNvPr id="25" name="Text 23"/>
+          <p:cNvPr id="21" name="Text 19"/>
           <p:cNvSpPr txBox="1"/>
           <p:nvPr/>
         </p:nvSpPr>
         <p:spPr>
           <a:xfrm>
-            <a:off x="5257800" y="3108960"/>
-            <a:ext cx="457200" cy="603504"/>
+            <a:off x="5303520" y="3108960"/>
+            <a:ext cx="2834640" cy="603504"/>
           </a:xfrm>
           <a:prstGeom prst="rect">
             <a:avLst/>
@@ -15755,42 +15467,6 @@
               <a:buNone/>
             </a:pPr>
             <a:r>
-              <a:rPr lang="en-US" sz="1300" b="1" dirty="0">
-                <a:solidFill>
-                  <a:schemeClr val="accent2"/>
-                </a:solidFill>
-              </a:rPr>
-              <a:t>05</a:t>
-            </a:r>
-            <a:endParaRPr lang="en-US" sz="1300" dirty="0"/>
-          </a:p>
-        </p:txBody>
-      </p:sp>
-      <p:sp>
-        <p:nvSpPr>
-          <p:cNvPr id="26" name="Text 24"/>
-          <p:cNvSpPr txBox="1"/>
-          <p:nvPr/>
-        </p:nvSpPr>
-        <p:spPr>
-          <a:xfrm>
-            <a:off x="5715000" y="3108960"/>
-            <a:ext cx="2423160" cy="603504"/>
-          </a:xfrm>
-          <a:prstGeom prst="rect">
-            <a:avLst/>
-          </a:prstGeom>
-          <a:noFill/>
-          <a:ln/>
-        </p:spPr>
-        <p:txBody>
-          <a:bodyPr wrap="square" lIns="0" tIns="0" rIns="0" bIns="0" rtlCol="0" anchor="ctr"/>
-          <a:lstStyle/>
-          <a:p>
-            <a:pPr indent="0" marL="0">
-              <a:buNone/>
-            </a:pPr>
-            <a:r>
               <a:rPr lang="en-US" sz="1500" b="1" dirty="0">
                 <a:solidFill>
                   <a:schemeClr val="tx1"/>
@@ -15804,7 +15480,7 @@
       </p:sp>
       <p:sp>
         <p:nvSpPr>
-          <p:cNvPr id="27" name="Carte"/>
+          <p:cNvPr id="22" name="Carte"/>
           <p:cNvSpPr/>
           <p:nvPr/>
         </p:nvSpPr>
@@ -15831,14 +15507,14 @@
       </p:sp>
       <p:sp>
         <p:nvSpPr>
-          <p:cNvPr id="28" name="Text 26"/>
+          <p:cNvPr id="23" name="Text 21"/>
           <p:cNvSpPr txBox="1"/>
           <p:nvPr/>
         </p:nvSpPr>
         <p:spPr>
           <a:xfrm>
-            <a:off x="8549640" y="3108960"/>
-            <a:ext cx="457200" cy="603504"/>
+            <a:off x="8595360" y="3108960"/>
+            <a:ext cx="2834640" cy="603504"/>
           </a:xfrm>
           <a:prstGeom prst="rect">
             <a:avLst/>
@@ -15854,42 +15530,6 @@
               <a:buNone/>
             </a:pPr>
             <a:r>
-              <a:rPr lang="en-US" sz="1300" b="1" dirty="0">
-                <a:solidFill>
-                  <a:schemeClr val="accent2"/>
-                </a:solidFill>
-              </a:rPr>
-              <a:t>06</a:t>
-            </a:r>
-            <a:endParaRPr lang="en-US" sz="1300" dirty="0"/>
-          </a:p>
-        </p:txBody>
-      </p:sp>
-      <p:sp>
-        <p:nvSpPr>
-          <p:cNvPr id="29" name="Text 27"/>
-          <p:cNvSpPr txBox="1"/>
-          <p:nvPr/>
-        </p:nvSpPr>
-        <p:spPr>
-          <a:xfrm>
-            <a:off x="9006840" y="3108960"/>
-            <a:ext cx="2423160" cy="603504"/>
-          </a:xfrm>
-          <a:prstGeom prst="rect">
-            <a:avLst/>
-          </a:prstGeom>
-          <a:noFill/>
-          <a:ln/>
-        </p:spPr>
-        <p:txBody>
-          <a:bodyPr wrap="square" lIns="0" tIns="0" rIns="0" bIns="0" rtlCol="0" anchor="ctr"/>
-          <a:lstStyle/>
-          <a:p>
-            <a:pPr indent="0" marL="0">
-              <a:buNone/>
-            </a:pPr>
-            <a:r>
               <a:rPr lang="en-US" sz="1500" b="1" dirty="0">
                 <a:solidFill>
                   <a:schemeClr val="tx1"/>
@@ -15903,7 +15543,7 @@
       </p:sp>
       <p:sp>
         <p:nvSpPr>
-          <p:cNvPr id="30" name="Carte"/>
+          <p:cNvPr id="24" name="Carte"/>
           <p:cNvSpPr/>
           <p:nvPr/>
         </p:nvSpPr>
@@ -15930,14 +15570,14 @@
       </p:sp>
       <p:sp>
         <p:nvSpPr>
-          <p:cNvPr id="31" name="Text 29"/>
+          <p:cNvPr id="25" name="Text 23"/>
           <p:cNvSpPr txBox="1"/>
           <p:nvPr/>
         </p:nvSpPr>
         <p:spPr>
           <a:xfrm>
-            <a:off x="5257800" y="3840480"/>
-            <a:ext cx="457200" cy="603504"/>
+            <a:off x="5303520" y="3840480"/>
+            <a:ext cx="2834640" cy="603504"/>
           </a:xfrm>
           <a:prstGeom prst="rect">
             <a:avLst/>
@@ -15953,42 +15593,6 @@
               <a:buNone/>
             </a:pPr>
             <a:r>
-              <a:rPr lang="en-US" sz="1300" b="1" dirty="0">
-                <a:solidFill>
-                  <a:schemeClr val="accent2"/>
-                </a:solidFill>
-              </a:rPr>
-              <a:t>07</a:t>
-            </a:r>
-            <a:endParaRPr lang="en-US" sz="1300" dirty="0"/>
-          </a:p>
-        </p:txBody>
-      </p:sp>
-      <p:sp>
-        <p:nvSpPr>
-          <p:cNvPr id="32" name="Text 30"/>
-          <p:cNvSpPr txBox="1"/>
-          <p:nvPr/>
-        </p:nvSpPr>
-        <p:spPr>
-          <a:xfrm>
-            <a:off x="5715000" y="3840480"/>
-            <a:ext cx="2423160" cy="603504"/>
-          </a:xfrm>
-          <a:prstGeom prst="rect">
-            <a:avLst/>
-          </a:prstGeom>
-          <a:noFill/>
-          <a:ln/>
-        </p:spPr>
-        <p:txBody>
-          <a:bodyPr wrap="square" lIns="0" tIns="0" rIns="0" bIns="0" rtlCol="0" anchor="ctr"/>
-          <a:lstStyle/>
-          <a:p>
-            <a:pPr indent="0" marL="0">
-              <a:buNone/>
-            </a:pPr>
-            <a:r>
               <a:rPr lang="en-US" sz="1500" b="1" dirty="0">
                 <a:solidFill>
                   <a:schemeClr val="tx1"/>
@@ -16002,7 +15606,7 @@
       </p:sp>
       <p:sp>
         <p:nvSpPr>
-          <p:cNvPr id="33" name="Carte"/>
+          <p:cNvPr id="26" name="Carte"/>
           <p:cNvSpPr/>
           <p:nvPr/>
         </p:nvSpPr>
@@ -16029,14 +15633,14 @@
       </p:sp>
       <p:sp>
         <p:nvSpPr>
-          <p:cNvPr id="34" name="Text 32"/>
+          <p:cNvPr id="27" name="Text 25"/>
           <p:cNvSpPr txBox="1"/>
           <p:nvPr/>
         </p:nvSpPr>
         <p:spPr>
           <a:xfrm>
-            <a:off x="8549640" y="3840480"/>
-            <a:ext cx="457200" cy="603504"/>
+            <a:off x="8595360" y="3840480"/>
+            <a:ext cx="2834640" cy="603504"/>
           </a:xfrm>
           <a:prstGeom prst="rect">
             <a:avLst/>
@@ -16052,42 +15656,6 @@
               <a:buNone/>
             </a:pPr>
             <a:r>
-              <a:rPr lang="en-US" sz="1300" b="1" dirty="0">
-                <a:solidFill>
-                  <a:schemeClr val="accent2"/>
-                </a:solidFill>
-              </a:rPr>
-              <a:t>08</a:t>
-            </a:r>
-            <a:endParaRPr lang="en-US" sz="1300" dirty="0"/>
-          </a:p>
-        </p:txBody>
-      </p:sp>
-      <p:sp>
-        <p:nvSpPr>
-          <p:cNvPr id="35" name="Text 33"/>
-          <p:cNvSpPr txBox="1"/>
-          <p:nvPr/>
-        </p:nvSpPr>
-        <p:spPr>
-          <a:xfrm>
-            <a:off x="9006840" y="3840480"/>
-            <a:ext cx="2423160" cy="603504"/>
-          </a:xfrm>
-          <a:prstGeom prst="rect">
-            <a:avLst/>
-          </a:prstGeom>
-          <a:noFill/>
-          <a:ln/>
-        </p:spPr>
-        <p:txBody>
-          <a:bodyPr wrap="square" lIns="0" tIns="0" rIns="0" bIns="0" rtlCol="0" anchor="ctr"/>
-          <a:lstStyle/>
-          <a:p>
-            <a:pPr indent="0" marL="0">
-              <a:buNone/>
-            </a:pPr>
-            <a:r>
               <a:rPr lang="en-US" sz="1500" b="1" dirty="0">
                 <a:solidFill>
                   <a:schemeClr val="tx1"/>
@@ -16101,7 +15669,7 @@
       </p:sp>
       <p:sp>
         <p:nvSpPr>
-          <p:cNvPr id="36" name="Carte"/>
+          <p:cNvPr id="28" name="Carte"/>
           <p:cNvSpPr/>
           <p:nvPr/>
         </p:nvSpPr>
@@ -16128,14 +15696,14 @@
       </p:sp>
       <p:sp>
         <p:nvSpPr>
-          <p:cNvPr id="37" name="Text 35"/>
+          <p:cNvPr id="29" name="Text 27"/>
           <p:cNvSpPr txBox="1"/>
           <p:nvPr/>
         </p:nvSpPr>
         <p:spPr>
           <a:xfrm>
-            <a:off x="5257800" y="4572000"/>
-            <a:ext cx="457200" cy="603504"/>
+            <a:off x="5303520" y="4572000"/>
+            <a:ext cx="2834640" cy="603504"/>
           </a:xfrm>
           <a:prstGeom prst="rect">
             <a:avLst/>
@@ -16151,42 +15719,6 @@
               <a:buNone/>
             </a:pPr>
             <a:r>
-              <a:rPr lang="en-US" sz="1300" b="1" dirty="0">
-                <a:solidFill>
-                  <a:schemeClr val="accent2"/>
-                </a:solidFill>
-              </a:rPr>
-              <a:t>09</a:t>
-            </a:r>
-            <a:endParaRPr lang="en-US" sz="1300" dirty="0"/>
-          </a:p>
-        </p:txBody>
-      </p:sp>
-      <p:sp>
-        <p:nvSpPr>
-          <p:cNvPr id="38" name="Text 36"/>
-          <p:cNvSpPr txBox="1"/>
-          <p:nvPr/>
-        </p:nvSpPr>
-        <p:spPr>
-          <a:xfrm>
-            <a:off x="5715000" y="4572000"/>
-            <a:ext cx="2423160" cy="603504"/>
-          </a:xfrm>
-          <a:prstGeom prst="rect">
-            <a:avLst/>
-          </a:prstGeom>
-          <a:noFill/>
-          <a:ln/>
-        </p:spPr>
-        <p:txBody>
-          <a:bodyPr wrap="square" lIns="0" tIns="0" rIns="0" bIns="0" rtlCol="0" anchor="ctr"/>
-          <a:lstStyle/>
-          <a:p>
-            <a:pPr indent="0" marL="0">
-              <a:buNone/>
-            </a:pPr>
-            <a:r>
               <a:rPr lang="en-US" sz="1500" b="1" dirty="0">
                 <a:solidFill>
                   <a:schemeClr val="tx1"/>
@@ -16200,7 +15732,7 @@
       </p:sp>
       <p:sp>
         <p:nvSpPr>
-          <p:cNvPr id="39" name="Carte"/>
+          <p:cNvPr id="30" name="Carte"/>
           <p:cNvSpPr/>
           <p:nvPr/>
         </p:nvSpPr>
@@ -16227,14 +15759,14 @@
       </p:sp>
       <p:sp>
         <p:nvSpPr>
-          <p:cNvPr id="40" name="Text 38"/>
+          <p:cNvPr id="31" name="Text 29"/>
           <p:cNvSpPr txBox="1"/>
           <p:nvPr/>
         </p:nvSpPr>
         <p:spPr>
           <a:xfrm>
-            <a:off x="8549640" y="4572000"/>
-            <a:ext cx="457200" cy="603504"/>
+            <a:off x="8595360" y="4572000"/>
+            <a:ext cx="2834640" cy="603504"/>
           </a:xfrm>
           <a:prstGeom prst="rect">
             <a:avLst/>
@@ -16250,42 +15782,6 @@
               <a:buNone/>
             </a:pPr>
             <a:r>
-              <a:rPr lang="en-US" sz="1300" b="1" dirty="0">
-                <a:solidFill>
-                  <a:schemeClr val="accent2"/>
-                </a:solidFill>
-              </a:rPr>
-              <a:t>10</a:t>
-            </a:r>
-            <a:endParaRPr lang="en-US" sz="1300" dirty="0"/>
-          </a:p>
-        </p:txBody>
-      </p:sp>
-      <p:sp>
-        <p:nvSpPr>
-          <p:cNvPr id="41" name="Text 39"/>
-          <p:cNvSpPr txBox="1"/>
-          <p:nvPr/>
-        </p:nvSpPr>
-        <p:spPr>
-          <a:xfrm>
-            <a:off x="9006840" y="4572000"/>
-            <a:ext cx="2423160" cy="603504"/>
-          </a:xfrm>
-          <a:prstGeom prst="rect">
-            <a:avLst/>
-          </a:prstGeom>
-          <a:noFill/>
-          <a:ln/>
-        </p:spPr>
-        <p:txBody>
-          <a:bodyPr wrap="square" lIns="0" tIns="0" rIns="0" bIns="0" rtlCol="0" anchor="ctr"/>
-          <a:lstStyle/>
-          <a:p>
-            <a:pPr indent="0" marL="0">
-              <a:buNone/>
-            </a:pPr>
-            <a:r>
               <a:rPr lang="en-US" sz="1500" b="1" dirty="0">
                 <a:solidFill>
                   <a:schemeClr val="tx1"/>
@@ -16299,7 +15795,7 @@
       </p:sp>
       <p:sp>
         <p:nvSpPr>
-          <p:cNvPr id="42" name="Pastille"/>
+          <p:cNvPr id="32" name="Pastille"/>
           <p:cNvSpPr/>
           <p:nvPr/>
         </p:nvSpPr>
@@ -16330,7 +15826,7 @@
       </p:sp>
       <p:sp>
         <p:nvSpPr>
-          <p:cNvPr id="43" name="Pastille texte"/>
+          <p:cNvPr id="33" name="Pastille texte"/>
           <p:cNvSpPr txBox="1"/>
           <p:nvPr/>
         </p:nvSpPr>
@@ -16366,7 +15862,7 @@
       </p:sp>
       <p:sp>
         <p:nvSpPr>
-          <p:cNvPr id="44" name="Pastille"/>
+          <p:cNvPr id="34" name="Pastille"/>
           <p:cNvSpPr/>
           <p:nvPr/>
         </p:nvSpPr>
@@ -16397,7 +15893,7 @@
       </p:sp>
       <p:sp>
         <p:nvSpPr>
-          <p:cNvPr id="45" name="Pastille texte"/>
+          <p:cNvPr id="35" name="Pastille texte"/>
           <p:cNvSpPr txBox="1"/>
           <p:nvPr/>
         </p:nvSpPr>
@@ -16433,7 +15929,7 @@
       </p:sp>
       <p:sp>
         <p:nvSpPr>
-          <p:cNvPr id="46" name="Pastille"/>
+          <p:cNvPr id="36" name="Pastille"/>
           <p:cNvSpPr/>
           <p:nvPr/>
         </p:nvSpPr>
@@ -16464,7 +15960,7 @@
       </p:sp>
       <p:sp>
         <p:nvSpPr>
-          <p:cNvPr id="47" name="Pastille texte"/>
+          <p:cNvPr id="37" name="Pastille texte"/>
           <p:cNvSpPr txBox="1"/>
           <p:nvPr/>
         </p:nvSpPr>

</xml_diff>